<commit_message>
Atualiza mapa EFC com Km 85, Pindaré, 763+800 e ANA
Inclui HTML/PNG com marcadores distintos e legenda, resumo JSON
com distâncias à ANA mais próxima, e slides no PPTX. Planilhas
xlsx locais ainda não disponíveis nesta VM.

Co-authored-by: gabrielavitelli <gabrielavitelli@users.noreply.github.com>
</commit_message>
<xml_diff>
--- a/Km661_Ponte_Sumauma_nivel_ultimos_30dias.pptx
+++ b/Km661_Ponte_Sumauma_nivel_ultimos_30dias.pptx
@@ -10,6 +10,10 @@
     <p:sldId id="258" r:id="rId9"/>
     <p:sldId id="259" r:id="rId10"/>
     <p:sldId id="260" r:id="rId11"/>
+    <p:sldId id="261" r:id="rId12"/>
+    <p:sldId id="262" r:id="rId13"/>
+    <p:sldId id="263" r:id="rId14"/>
+    <p:sldId id="264" r:id="rId15"/>
   </p:sldIdLst>
   <p:sldSz cx="12191695" cy="6858000" type="screen4x3"/>
   <p:notesSz cx="6858000" cy="9144000"/>
@@ -4331,6 +4335,1128 @@
           </a:p>
         </p:txBody>
       </p:sp>
+    </p:spTree>
+  </p:cSld>
+  <p:clrMapOvr>
+    <a:masterClrMapping/>
+  </p:clrMapOvr>
+</p:sld>
+</file>
+
+<file path=ppt/slides/slide6.xml><?xml version="1.0" encoding="utf-8"?>
+<p:sld xmlns:a="http://schemas.openxmlformats.org/drawingml/2006/main" xmlns:p="http://schemas.openxmlformats.org/presentationml/2006/main" xmlns:r="http://schemas.openxmlformats.org/officeDocument/2006/relationships">
+  <p:cSld>
+    <p:spTree>
+      <p:nvGrpSpPr>
+        <p:cNvPr id="1" name=""/>
+        <p:cNvGrpSpPr/>
+        <p:nvPr/>
+      </p:nvGrpSpPr>
+      <p:grpSpPr/>
+      <p:sp>
+        <p:nvSpPr>
+          <p:cNvPr id="2" name="Rectangle 1"/>
+          <p:cNvSpPr/>
+          <p:nvPr/>
+        </p:nvSpPr>
+        <p:spPr>
+          <a:xfrm>
+            <a:off x="0" y="0"/>
+            <a:ext cx="12191695" cy="868680"/>
+          </a:xfrm>
+          <a:prstGeom prst="rect">
+            <a:avLst/>
+          </a:prstGeom>
+          <a:solidFill>
+            <a:srgbClr val="0C4A6E"/>
+          </a:solidFill>
+          <a:ln>
+            <a:noFill/>
+          </a:ln>
+        </p:spPr>
+        <p:style>
+          <a:lnRef idx="1">
+            <a:schemeClr val="accent1"/>
+          </a:lnRef>
+          <a:fillRef idx="3">
+            <a:schemeClr val="accent1"/>
+          </a:fillRef>
+          <a:effectRef idx="2">
+            <a:schemeClr val="accent1"/>
+          </a:effectRef>
+          <a:fontRef idx="minor">
+            <a:schemeClr val="lt1"/>
+          </a:fontRef>
+        </p:style>
+        <p:txBody>
+          <a:bodyPr rtlCol="0" anchor="ctr"/>
+          <a:lstStyle/>
+          <a:p>
+            <a:pPr algn="ctr"/>
+          </a:p>
+        </p:txBody>
+      </p:sp>
+      <p:sp>
+        <p:nvSpPr>
+          <p:cNvPr id="3" name="TextBox 2"/>
+          <p:cNvSpPr txBox="1"/>
+          <p:nvPr/>
+        </p:nvSpPr>
+        <p:spPr>
+          <a:xfrm>
+            <a:off x="457200" y="228600"/>
+            <a:ext cx="10972800" cy="502920"/>
+          </a:xfrm>
+          <a:prstGeom prst="rect">
+            <a:avLst/>
+          </a:prstGeom>
+          <a:noFill/>
+        </p:spPr>
+        <p:txBody>
+          <a:bodyPr wrap="none">
+            <a:spAutoFit/>
+          </a:bodyPr>
+          <a:lstStyle/>
+          <a:p>
+            <a:r>
+              <a:rPr sz="2200" b="1">
+                <a:solidFill>
+                  <a:srgbClr val="FFFFFF"/>
+                </a:solidFill>
+                <a:latin typeface="Calibri"/>
+              </a:rPr>
+              <a:t>Novos pontos EFC de nível — localização e ANA mais próxima</a:t>
+            </a:r>
+          </a:p>
+        </p:txBody>
+      </p:sp>
+      <p:graphicFrame>
+        <p:nvGraphicFramePr>
+          <p:cNvPr id="4" name="Table 3"/>
+          <p:cNvGraphicFramePr>
+            <a:graphicFrameLocks noGrp="1"/>
+          </p:cNvGraphicFramePr>
+          <p:nvPr/>
+        </p:nvGraphicFramePr>
+        <p:xfrm>
+          <a:off x="365760" y="1097280"/>
+          <a:ext cx="11430000" cy="1645920"/>
+        </p:xfrm>
+        <a:graphic>
+          <a:graphicData uri="http://schemas.openxmlformats.org/drawingml/2006/table">
+            <a:tbl>
+              <a:tblPr firstRow="1" bandRow="1">
+                <a:tableStyleId>{5C22544A-7EE6-4342-B048-85BDC9FD1C3A}</a:tableStyleId>
+              </a:tblPr>
+              <a:tblGrid>
+                <a:gridCol w="1905000"/>
+                <a:gridCol w="1905000"/>
+                <a:gridCol w="1905000"/>
+                <a:gridCol w="1905000"/>
+                <a:gridCol w="1905000"/>
+                <a:gridCol w="1905000"/>
+              </a:tblGrid>
+              <a:tr h="411480">
+                <a:tc>
+                  <a:txBody>
+                    <a:bodyPr/>
+                    <a:lstStyle/>
+                    <a:p>
+                      <a:r>
+                        <a:rPr sz="1100" b="1"/>
+                        <a:t>Ponto</a:t>
+                      </a:r>
+                    </a:p>
+                  </a:txBody>
+                  <a:tcPr/>
+                </a:tc>
+                <a:tc>
+                  <a:txBody>
+                    <a:bodyPr/>
+                    <a:lstStyle/>
+                    <a:p>
+                      <a:r>
+                        <a:rPr sz="1100" b="1"/>
+                        <a:t>Código</a:t>
+                      </a:r>
+                    </a:p>
+                  </a:txBody>
+                  <a:tcPr/>
+                </a:tc>
+                <a:tc>
+                  <a:txBody>
+                    <a:bodyPr/>
+                    <a:lstStyle/>
+                    <a:p>
+                      <a:r>
+                        <a:rPr sz="1100" b="1"/>
+                        <a:t>Lat</a:t>
+                      </a:r>
+                    </a:p>
+                  </a:txBody>
+                  <a:tcPr/>
+                </a:tc>
+                <a:tc>
+                  <a:txBody>
+                    <a:bodyPr/>
+                    <a:lstStyle/>
+                    <a:p>
+                      <a:r>
+                        <a:rPr sz="1100" b="1"/>
+                        <a:t>Lon</a:t>
+                      </a:r>
+                    </a:p>
+                  </a:txBody>
+                  <a:tcPr/>
+                </a:tc>
+                <a:tc>
+                  <a:txBody>
+                    <a:bodyPr/>
+                    <a:lstStyle/>
+                    <a:p>
+                      <a:r>
+                        <a:rPr sz="1100" b="1"/>
+                        <a:t>ANA mais próxima</a:t>
+                      </a:r>
+                    </a:p>
+                  </a:txBody>
+                  <a:tcPr/>
+                </a:tc>
+                <a:tc>
+                  <a:txBody>
+                    <a:bodyPr/>
+                    <a:lstStyle/>
+                    <a:p>
+                      <a:r>
+                        <a:rPr sz="1100" b="1"/>
+                        <a:t>Dist. (km)</a:t>
+                      </a:r>
+                    </a:p>
+                  </a:txBody>
+                  <a:tcPr/>
+                </a:tc>
+              </a:tr>
+              <a:tr h="411480">
+                <a:tc>
+                  <a:txBody>
+                    <a:bodyPr/>
+                    <a:lstStyle/>
+                    <a:p>
+                      <a:r>
+                        <a:rPr sz="1100"/>
+                        <a:t>Km 85</a:t>
+                      </a:r>
+                    </a:p>
+                  </a:txBody>
+                  <a:tcPr/>
+                </a:tc>
+                <a:tc>
+                  <a:txBody>
+                    <a:bodyPr/>
+                    <a:lstStyle/>
+                    <a:p>
+                      <a:r>
+                        <a:rPr sz="1100"/>
+                        <a:t>km85</a:t>
+                      </a:r>
+                    </a:p>
+                  </a:txBody>
+                  <a:tcPr/>
+                </a:tc>
+                <a:tc>
+                  <a:txBody>
+                    <a:bodyPr/>
+                    <a:lstStyle/>
+                    <a:p>
+                      <a:r>
+                        <a:rPr sz="1100"/>
+                        <a:t>-3.298651</a:t>
+                      </a:r>
+                    </a:p>
+                  </a:txBody>
+                  <a:tcPr/>
+                </a:tc>
+                <a:tc>
+                  <a:txBody>
+                    <a:bodyPr/>
+                    <a:lstStyle/>
+                    <a:p>
+                      <a:r>
+                        <a:rPr sz="1100"/>
+                        <a:t>-44.465063</a:t>
+                      </a:r>
+                    </a:p>
+                  </a:txBody>
+                  <a:tcPr/>
+                </a:tc>
+                <a:tc>
+                  <a:txBody>
+                    <a:bodyPr/>
+                    <a:lstStyle/>
+                    <a:p>
+                      <a:r>
+                        <a:rPr sz="1100"/>
+                        <a:t>23800495 · RIO TOCANTINS - SÃO SEBASTIÃO DO</a:t>
+                      </a:r>
+                    </a:p>
+                  </a:txBody>
+                  <a:tcPr/>
+                </a:tc>
+                <a:tc>
+                  <a:txBody>
+                    <a:bodyPr/>
+                    <a:lstStyle/>
+                    <a:p>
+                      <a:r>
+                        <a:rPr sz="1100"/>
+                        <a:t>467.6</a:t>
+                      </a:r>
+                    </a:p>
+                  </a:txBody>
+                  <a:tcPr/>
+                </a:tc>
+              </a:tr>
+              <a:tr h="411480">
+                <a:tc>
+                  <a:txBody>
+                    <a:bodyPr/>
+                    <a:lstStyle/>
+                    <a:p>
+                      <a:r>
+                        <a:rPr sz="1100"/>
+                        <a:t>Sensor Rio Pindaré</a:t>
+                      </a:r>
+                    </a:p>
+                  </a:txBody>
+                  <a:tcPr/>
+                </a:tc>
+                <a:tc>
+                  <a:txBody>
+                    <a:bodyPr/>
+                    <a:lstStyle/>
+                    <a:p>
+                      <a:r>
+                        <a:rPr sz="1100"/>
+                        <a:t>BC07541S</a:t>
+                      </a:r>
+                    </a:p>
+                  </a:txBody>
+                  <a:tcPr/>
+                </a:tc>
+                <a:tc>
+                  <a:txBody>
+                    <a:bodyPr/>
+                    <a:lstStyle/>
+                    <a:p>
+                      <a:r>
+                        <a:rPr sz="1100"/>
+                        <a:t>-4.253738</a:t>
+                      </a:r>
+                    </a:p>
+                  </a:txBody>
+                  <a:tcPr/>
+                </a:tc>
+                <a:tc>
+                  <a:txBody>
+                    <a:bodyPr/>
+                    <a:lstStyle/>
+                    <a:p>
+                      <a:r>
+                        <a:rPr sz="1100"/>
+                        <a:t>-46.531145</a:t>
+                      </a:r>
+                    </a:p>
+                  </a:txBody>
+                  <a:tcPr/>
+                </a:tc>
+                <a:tc>
+                  <a:txBody>
+                    <a:bodyPr/>
+                    <a:lstStyle/>
+                    <a:p>
+                      <a:r>
+                        <a:rPr sz="1100"/>
+                        <a:t>23800495 · RIO TOCANTINS - SÃO SEBASTIÃO DO</a:t>
+                      </a:r>
+                    </a:p>
+                  </a:txBody>
+                  <a:tcPr/>
+                </a:tc>
+                <a:tc>
+                  <a:txBody>
+                    <a:bodyPr/>
+                    <a:lstStyle/>
+                    <a:p>
+                      <a:r>
+                        <a:rPr sz="1100"/>
+                        <a:t>215.7</a:t>
+                      </a:r>
+                    </a:p>
+                  </a:txBody>
+                  <a:tcPr/>
+                </a:tc>
+              </a:tr>
+              <a:tr h="411480">
+                <a:tc>
+                  <a:txBody>
+                    <a:bodyPr/>
+                    <a:lstStyle/>
+                    <a:p>
+                      <a:r>
+                        <a:rPr sz="1100"/>
+                        <a:t>Ponte 763+800</a:t>
+                      </a:r>
+                    </a:p>
+                  </a:txBody>
+                  <a:tcPr/>
+                </a:tc>
+                <a:tc>
+                  <a:txBody>
+                    <a:bodyPr/>
+                    <a:lstStyle/>
+                    <a:p>
+                      <a:r>
+                        <a:rPr sz="1100"/>
+                        <a:t>BC07533S</a:t>
+                      </a:r>
+                    </a:p>
+                  </a:txBody>
+                  <a:tcPr/>
+                </a:tc>
+                <a:tc>
+                  <a:txBody>
+                    <a:bodyPr/>
+                    <a:lstStyle/>
+                    <a:p>
+                      <a:r>
+                        <a:rPr sz="1100"/>
+                        <a:t>-5.571403</a:t>
+                      </a:r>
+                    </a:p>
+                  </a:txBody>
+                  <a:tcPr/>
+                </a:tc>
+                <a:tc>
+                  <a:txBody>
+                    <a:bodyPr/>
+                    <a:lstStyle/>
+                    <a:p>
+                      <a:r>
+                        <a:rPr sz="1100"/>
+                        <a:t>-49.241924</a:t>
+                      </a:r>
+                    </a:p>
+                  </a:txBody>
+                  <a:tcPr/>
+                </a:tc>
+                <a:tc>
+                  <a:txBody>
+                    <a:bodyPr/>
+                    <a:lstStyle/>
+                    <a:p>
+                      <a:r>
+                        <a:rPr sz="1100"/>
+                        <a:t>29050000 · MARABÁ</a:t>
+                      </a:r>
+                    </a:p>
+                  </a:txBody>
+                  <a:tcPr/>
+                </a:tc>
+                <a:tc>
+                  <a:txBody>
+                    <a:bodyPr/>
+                    <a:lstStyle/>
+                    <a:p>
+                      <a:r>
+                        <a:rPr sz="1100"/>
+                        <a:t>29.0</a:t>
+                      </a:r>
+                    </a:p>
+                  </a:txBody>
+                  <a:tcPr/>
+                </a:tc>
+              </a:tr>
+            </a:tbl>
+          </a:graphicData>
+        </a:graphic>
+      </p:graphicFrame>
+      <p:sp>
+        <p:nvSpPr>
+          <p:cNvPr id="5" name="TextBox 4"/>
+          <p:cNvSpPr txBox="1"/>
+          <p:nvPr/>
+        </p:nvSpPr>
+        <p:spPr>
+          <a:xfrm>
+            <a:off x="457200" y="3200400"/>
+            <a:ext cx="11247120" cy="3200400"/>
+          </a:xfrm>
+          <a:prstGeom prst="rect">
+            <a:avLst/>
+          </a:prstGeom>
+          <a:noFill/>
+        </p:spPr>
+        <p:txBody>
+          <a:bodyPr wrap="square">
+            <a:spAutoFit/>
+          </a:bodyPr>
+          <a:lstStyle/>
+          <a:p>
+            <a:r>
+              <a:rPr sz="1300" b="0">
+                <a:solidFill>
+                  <a:srgbClr val="283C50"/>
+                </a:solidFill>
+                <a:latin typeface="Calibri"/>
+              </a:rPr>
+              <a:t>Detalhamento (coordenadas fornecidas · planilhas xlsx ainda não incorporadas nesta VM)
+• Km 85 (km85): -3.298651, -44.465063 — ANA 23800495 (RIO TOCANTINS - SÃO SEBASTIÃO DO TO) a 467.6 km
+• Sensor Rio Pindaré (BC07541S): -4.253738, -46.531145 — ANA 23800495 (RIO TOCANTINS - SÃO SEBASTIÃO DO TO) a 215.7 km
+• Ponte 763+800 (BC07533S): -5.571403, -49.241924 — ANA 29050000 (MARABÁ) a 29.0 km
+• Km 661 Ponte Sumaúma permanece o foco do relatório de nível (30 dias) com as 4 ANA priorizadas.
+• Para enriquecer popups com séries das planilhas, enviar os 3 xlsx para gs://efc-clima-data/reports/km661_ponte_sumauma/entrada/
+• Atualizado em 2026-10-13 19:16</a:t>
+            </a:r>
+          </a:p>
+        </p:txBody>
+      </p:sp>
+    </p:spTree>
+  </p:cSld>
+  <p:clrMapOvr>
+    <a:masterClrMapping/>
+  </p:clrMapOvr>
+</p:sld>
+</file>
+
+<file path=ppt/slides/slide7.xml><?xml version="1.0" encoding="utf-8"?>
+<p:sld xmlns:a="http://schemas.openxmlformats.org/drawingml/2006/main" xmlns:p="http://schemas.openxmlformats.org/presentationml/2006/main" xmlns:r="http://schemas.openxmlformats.org/officeDocument/2006/relationships">
+  <p:cSld>
+    <p:spTree>
+      <p:nvGrpSpPr>
+        <p:cNvPr id="1" name=""/>
+        <p:cNvGrpSpPr/>
+        <p:nvPr/>
+      </p:nvGrpSpPr>
+      <p:grpSpPr/>
+      <p:sp>
+        <p:nvSpPr>
+          <p:cNvPr id="2" name="TextBox 1"/>
+          <p:cNvSpPr txBox="1"/>
+          <p:nvPr/>
+        </p:nvSpPr>
+        <p:spPr>
+          <a:xfrm>
+            <a:off x="457200" y="182880"/>
+            <a:ext cx="10972800" cy="457200"/>
+          </a:xfrm>
+          <a:prstGeom prst="rect">
+            <a:avLst/>
+          </a:prstGeom>
+          <a:noFill/>
+        </p:spPr>
+        <p:txBody>
+          <a:bodyPr wrap="none">
+            <a:spAutoFit/>
+          </a:bodyPr>
+          <a:lstStyle/>
+          <a:p>
+            <a:r>
+              <a:rPr sz="2000" b="1">
+                <a:solidFill>
+                  <a:srgbClr val="0C3250"/>
+                </a:solidFill>
+                <a:latin typeface="Calibri"/>
+              </a:rPr>
+              <a:t>Mapa atualizado — pontos EFC de nível + ANA</a:t>
+            </a:r>
+          </a:p>
+        </p:txBody>
+      </p:sp>
+      <p:pic>
+        <p:nvPicPr>
+          <p:cNvPr id="3" name="Picture 2" descr="EFC_pontos_nivel_mapa.png"/>
+          <p:cNvPicPr>
+            <a:picLocks noChangeAspect="1"/>
+          </p:cNvPicPr>
+          <p:nvPr/>
+        </p:nvPicPr>
+        <p:blipFill>
+          <a:blip r:embed="rId2"/>
+          <a:stretch>
+            <a:fillRect/>
+          </a:stretch>
+        </p:blipFill>
+        <p:spPr>
+          <a:xfrm>
+            <a:off x="502920" y="731520"/>
+            <a:ext cx="11155680" cy="7684797"/>
+          </a:xfrm>
+          <a:prstGeom prst="rect">
+            <a:avLst/>
+          </a:prstGeom>
+        </p:spPr>
+      </p:pic>
+    </p:spTree>
+  </p:cSld>
+  <p:clrMapOvr>
+    <a:masterClrMapping/>
+  </p:clrMapOvr>
+</p:sld>
+</file>
+
+<file path=ppt/slides/slide8.xml><?xml version="1.0" encoding="utf-8"?>
+<p:sld xmlns:a="http://schemas.openxmlformats.org/drawingml/2006/main" xmlns:p="http://schemas.openxmlformats.org/presentationml/2006/main" xmlns:r="http://schemas.openxmlformats.org/officeDocument/2006/relationships">
+  <p:cSld>
+    <p:spTree>
+      <p:nvGrpSpPr>
+        <p:cNvPr id="1" name=""/>
+        <p:cNvGrpSpPr/>
+        <p:nvPr/>
+      </p:nvGrpSpPr>
+      <p:grpSpPr/>
+      <p:sp>
+        <p:nvSpPr>
+          <p:cNvPr id="2" name="Rectangle 1"/>
+          <p:cNvSpPr/>
+          <p:nvPr/>
+        </p:nvSpPr>
+        <p:spPr>
+          <a:xfrm>
+            <a:off x="0" y="0"/>
+            <a:ext cx="12191695" cy="868680"/>
+          </a:xfrm>
+          <a:prstGeom prst="rect">
+            <a:avLst/>
+          </a:prstGeom>
+          <a:solidFill>
+            <a:srgbClr val="0C4A6E"/>
+          </a:solidFill>
+          <a:ln>
+            <a:noFill/>
+          </a:ln>
+        </p:spPr>
+        <p:style>
+          <a:lnRef idx="1">
+            <a:schemeClr val="accent1"/>
+          </a:lnRef>
+          <a:fillRef idx="3">
+            <a:schemeClr val="accent1"/>
+          </a:fillRef>
+          <a:effectRef idx="2">
+            <a:schemeClr val="accent1"/>
+          </a:effectRef>
+          <a:fontRef idx="minor">
+            <a:schemeClr val="lt1"/>
+          </a:fontRef>
+        </p:style>
+        <p:txBody>
+          <a:bodyPr rtlCol="0" anchor="ctr"/>
+          <a:lstStyle/>
+          <a:p>
+            <a:pPr algn="ctr"/>
+          </a:p>
+        </p:txBody>
+      </p:sp>
+      <p:sp>
+        <p:nvSpPr>
+          <p:cNvPr id="3" name="TextBox 2"/>
+          <p:cNvSpPr txBox="1"/>
+          <p:nvPr/>
+        </p:nvSpPr>
+        <p:spPr>
+          <a:xfrm>
+            <a:off x="457200" y="228600"/>
+            <a:ext cx="10972800" cy="502920"/>
+          </a:xfrm>
+          <a:prstGeom prst="rect">
+            <a:avLst/>
+          </a:prstGeom>
+          <a:noFill/>
+        </p:spPr>
+        <p:txBody>
+          <a:bodyPr wrap="none">
+            <a:spAutoFit/>
+          </a:bodyPr>
+          <a:lstStyle/>
+          <a:p>
+            <a:r>
+              <a:rPr sz="2200" b="1">
+                <a:solidFill>
+                  <a:srgbClr val="FFFFFF"/>
+                </a:solidFill>
+                <a:latin typeface="Calibri"/>
+              </a:rPr>
+              <a:t>Novos pontos EFC de nível — localização e ANA mais próxima</a:t>
+            </a:r>
+          </a:p>
+        </p:txBody>
+      </p:sp>
+      <p:graphicFrame>
+        <p:nvGraphicFramePr>
+          <p:cNvPr id="4" name="Table 3"/>
+          <p:cNvGraphicFramePr>
+            <a:graphicFrameLocks noGrp="1"/>
+          </p:cNvGraphicFramePr>
+          <p:nvPr/>
+        </p:nvGraphicFramePr>
+        <p:xfrm>
+          <a:off x="365760" y="1097280"/>
+          <a:ext cx="11430000" cy="1645920"/>
+        </p:xfrm>
+        <a:graphic>
+          <a:graphicData uri="http://schemas.openxmlformats.org/drawingml/2006/table">
+            <a:tbl>
+              <a:tblPr firstRow="1" bandRow="1">
+                <a:tableStyleId>{5C22544A-7EE6-4342-B048-85BDC9FD1C3A}</a:tableStyleId>
+              </a:tblPr>
+              <a:tblGrid>
+                <a:gridCol w="1905000"/>
+                <a:gridCol w="1905000"/>
+                <a:gridCol w="1905000"/>
+                <a:gridCol w="1905000"/>
+                <a:gridCol w="1905000"/>
+                <a:gridCol w="1905000"/>
+              </a:tblGrid>
+              <a:tr h="411480">
+                <a:tc>
+                  <a:txBody>
+                    <a:bodyPr/>
+                    <a:lstStyle/>
+                    <a:p>
+                      <a:r>
+                        <a:rPr sz="1100" b="1"/>
+                        <a:t>Ponto</a:t>
+                      </a:r>
+                    </a:p>
+                  </a:txBody>
+                  <a:tcPr/>
+                </a:tc>
+                <a:tc>
+                  <a:txBody>
+                    <a:bodyPr/>
+                    <a:lstStyle/>
+                    <a:p>
+                      <a:r>
+                        <a:rPr sz="1100" b="1"/>
+                        <a:t>Código</a:t>
+                      </a:r>
+                    </a:p>
+                  </a:txBody>
+                  <a:tcPr/>
+                </a:tc>
+                <a:tc>
+                  <a:txBody>
+                    <a:bodyPr/>
+                    <a:lstStyle/>
+                    <a:p>
+                      <a:r>
+                        <a:rPr sz="1100" b="1"/>
+                        <a:t>Lat</a:t>
+                      </a:r>
+                    </a:p>
+                  </a:txBody>
+                  <a:tcPr/>
+                </a:tc>
+                <a:tc>
+                  <a:txBody>
+                    <a:bodyPr/>
+                    <a:lstStyle/>
+                    <a:p>
+                      <a:r>
+                        <a:rPr sz="1100" b="1"/>
+                        <a:t>Lon</a:t>
+                      </a:r>
+                    </a:p>
+                  </a:txBody>
+                  <a:tcPr/>
+                </a:tc>
+                <a:tc>
+                  <a:txBody>
+                    <a:bodyPr/>
+                    <a:lstStyle/>
+                    <a:p>
+                      <a:r>
+                        <a:rPr sz="1100" b="1"/>
+                        <a:t>ANA mais próxima</a:t>
+                      </a:r>
+                    </a:p>
+                  </a:txBody>
+                  <a:tcPr/>
+                </a:tc>
+                <a:tc>
+                  <a:txBody>
+                    <a:bodyPr/>
+                    <a:lstStyle/>
+                    <a:p>
+                      <a:r>
+                        <a:rPr sz="1100" b="1"/>
+                        <a:t>Dist. (km)</a:t>
+                      </a:r>
+                    </a:p>
+                  </a:txBody>
+                  <a:tcPr/>
+                </a:tc>
+              </a:tr>
+              <a:tr h="411480">
+                <a:tc>
+                  <a:txBody>
+                    <a:bodyPr/>
+                    <a:lstStyle/>
+                    <a:p>
+                      <a:r>
+                        <a:rPr sz="1100"/>
+                        <a:t>Km 85</a:t>
+                      </a:r>
+                    </a:p>
+                  </a:txBody>
+                  <a:tcPr/>
+                </a:tc>
+                <a:tc>
+                  <a:txBody>
+                    <a:bodyPr/>
+                    <a:lstStyle/>
+                    <a:p>
+                      <a:r>
+                        <a:rPr sz="1100"/>
+                        <a:t>km85</a:t>
+                      </a:r>
+                    </a:p>
+                  </a:txBody>
+                  <a:tcPr/>
+                </a:tc>
+                <a:tc>
+                  <a:txBody>
+                    <a:bodyPr/>
+                    <a:lstStyle/>
+                    <a:p>
+                      <a:r>
+                        <a:rPr sz="1100"/>
+                        <a:t>-3.298651</a:t>
+                      </a:r>
+                    </a:p>
+                  </a:txBody>
+                  <a:tcPr/>
+                </a:tc>
+                <a:tc>
+                  <a:txBody>
+                    <a:bodyPr/>
+                    <a:lstStyle/>
+                    <a:p>
+                      <a:r>
+                        <a:rPr sz="1100"/>
+                        <a:t>-44.465063</a:t>
+                      </a:r>
+                    </a:p>
+                  </a:txBody>
+                  <a:tcPr/>
+                </a:tc>
+                <a:tc>
+                  <a:txBody>
+                    <a:bodyPr/>
+                    <a:lstStyle/>
+                    <a:p>
+                      <a:r>
+                        <a:rPr sz="1100"/>
+                        <a:t>23800495 · RIO TOCANTINS - SÃO SEBASTIÃO DO</a:t>
+                      </a:r>
+                    </a:p>
+                  </a:txBody>
+                  <a:tcPr/>
+                </a:tc>
+                <a:tc>
+                  <a:txBody>
+                    <a:bodyPr/>
+                    <a:lstStyle/>
+                    <a:p>
+                      <a:r>
+                        <a:rPr sz="1100"/>
+                        <a:t>467.6</a:t>
+                      </a:r>
+                    </a:p>
+                  </a:txBody>
+                  <a:tcPr/>
+                </a:tc>
+              </a:tr>
+              <a:tr h="411480">
+                <a:tc>
+                  <a:txBody>
+                    <a:bodyPr/>
+                    <a:lstStyle/>
+                    <a:p>
+                      <a:r>
+                        <a:rPr sz="1100"/>
+                        <a:t>Sensor Rio Pindaré</a:t>
+                      </a:r>
+                    </a:p>
+                  </a:txBody>
+                  <a:tcPr/>
+                </a:tc>
+                <a:tc>
+                  <a:txBody>
+                    <a:bodyPr/>
+                    <a:lstStyle/>
+                    <a:p>
+                      <a:r>
+                        <a:rPr sz="1100"/>
+                        <a:t>BC07541S</a:t>
+                      </a:r>
+                    </a:p>
+                  </a:txBody>
+                  <a:tcPr/>
+                </a:tc>
+                <a:tc>
+                  <a:txBody>
+                    <a:bodyPr/>
+                    <a:lstStyle/>
+                    <a:p>
+                      <a:r>
+                        <a:rPr sz="1100"/>
+                        <a:t>-4.253738</a:t>
+                      </a:r>
+                    </a:p>
+                  </a:txBody>
+                  <a:tcPr/>
+                </a:tc>
+                <a:tc>
+                  <a:txBody>
+                    <a:bodyPr/>
+                    <a:lstStyle/>
+                    <a:p>
+                      <a:r>
+                        <a:rPr sz="1100"/>
+                        <a:t>-46.531145</a:t>
+                      </a:r>
+                    </a:p>
+                  </a:txBody>
+                  <a:tcPr/>
+                </a:tc>
+                <a:tc>
+                  <a:txBody>
+                    <a:bodyPr/>
+                    <a:lstStyle/>
+                    <a:p>
+                      <a:r>
+                        <a:rPr sz="1100"/>
+                        <a:t>23800495 · RIO TOCANTINS - SÃO SEBASTIÃO DO</a:t>
+                      </a:r>
+                    </a:p>
+                  </a:txBody>
+                  <a:tcPr/>
+                </a:tc>
+                <a:tc>
+                  <a:txBody>
+                    <a:bodyPr/>
+                    <a:lstStyle/>
+                    <a:p>
+                      <a:r>
+                        <a:rPr sz="1100"/>
+                        <a:t>215.7</a:t>
+                      </a:r>
+                    </a:p>
+                  </a:txBody>
+                  <a:tcPr/>
+                </a:tc>
+              </a:tr>
+              <a:tr h="411480">
+                <a:tc>
+                  <a:txBody>
+                    <a:bodyPr/>
+                    <a:lstStyle/>
+                    <a:p>
+                      <a:r>
+                        <a:rPr sz="1100"/>
+                        <a:t>Ponte 763+800</a:t>
+                      </a:r>
+                    </a:p>
+                  </a:txBody>
+                  <a:tcPr/>
+                </a:tc>
+                <a:tc>
+                  <a:txBody>
+                    <a:bodyPr/>
+                    <a:lstStyle/>
+                    <a:p>
+                      <a:r>
+                        <a:rPr sz="1100"/>
+                        <a:t>BC07533S</a:t>
+                      </a:r>
+                    </a:p>
+                  </a:txBody>
+                  <a:tcPr/>
+                </a:tc>
+                <a:tc>
+                  <a:txBody>
+                    <a:bodyPr/>
+                    <a:lstStyle/>
+                    <a:p>
+                      <a:r>
+                        <a:rPr sz="1100"/>
+                        <a:t>-5.571403</a:t>
+                      </a:r>
+                    </a:p>
+                  </a:txBody>
+                  <a:tcPr/>
+                </a:tc>
+                <a:tc>
+                  <a:txBody>
+                    <a:bodyPr/>
+                    <a:lstStyle/>
+                    <a:p>
+                      <a:r>
+                        <a:rPr sz="1100"/>
+                        <a:t>-49.241924</a:t>
+                      </a:r>
+                    </a:p>
+                  </a:txBody>
+                  <a:tcPr/>
+                </a:tc>
+                <a:tc>
+                  <a:txBody>
+                    <a:bodyPr/>
+                    <a:lstStyle/>
+                    <a:p>
+                      <a:r>
+                        <a:rPr sz="1100"/>
+                        <a:t>29050000 · MARABÁ</a:t>
+                      </a:r>
+                    </a:p>
+                  </a:txBody>
+                  <a:tcPr/>
+                </a:tc>
+                <a:tc>
+                  <a:txBody>
+                    <a:bodyPr/>
+                    <a:lstStyle/>
+                    <a:p>
+                      <a:r>
+                        <a:rPr sz="1100"/>
+                        <a:t>29.0</a:t>
+                      </a:r>
+                    </a:p>
+                  </a:txBody>
+                  <a:tcPr/>
+                </a:tc>
+              </a:tr>
+            </a:tbl>
+          </a:graphicData>
+        </a:graphic>
+      </p:graphicFrame>
+      <p:sp>
+        <p:nvSpPr>
+          <p:cNvPr id="5" name="TextBox 4"/>
+          <p:cNvSpPr txBox="1"/>
+          <p:nvPr/>
+        </p:nvSpPr>
+        <p:spPr>
+          <a:xfrm>
+            <a:off x="457200" y="3200400"/>
+            <a:ext cx="11247120" cy="3200400"/>
+          </a:xfrm>
+          <a:prstGeom prst="rect">
+            <a:avLst/>
+          </a:prstGeom>
+          <a:noFill/>
+        </p:spPr>
+        <p:txBody>
+          <a:bodyPr wrap="square">
+            <a:spAutoFit/>
+          </a:bodyPr>
+          <a:lstStyle/>
+          <a:p>
+            <a:r>
+              <a:rPr sz="1300" b="0">
+                <a:solidFill>
+                  <a:srgbClr val="283C50"/>
+                </a:solidFill>
+                <a:latin typeface="Calibri"/>
+              </a:rPr>
+              <a:t>Detalhamento (coordenadas fornecidas · planilhas xlsx ainda não incorporadas nesta VM)
+• Km 85 (km85): -3.298651, -44.465063 — ANA 23800495 (RIO TOCANTINS - SÃO SEBASTIÃO DO TO) a 467.6 km
+• Sensor Rio Pindaré (BC07541S): -4.253738, -46.531145 — ANA 23800495 (RIO TOCANTINS - SÃO SEBASTIÃO DO TO) a 215.7 km
+• Ponte 763+800 (BC07533S): -5.571403, -49.241924 — ANA 29050000 (MARABÁ) a 29.0 km
+• Km 661 Ponte Sumaúma permanece o foco do relatório de nível (30 dias) com as 4 ANA priorizadas.
+• Para enriquecer popups com séries das planilhas, enviar os 3 xlsx para gs://efc-clima-data/reports/km661_ponte_sumauma/entrada/
+• Atualizado em 2026-10-13 19:16</a:t>
+            </a:r>
+          </a:p>
+        </p:txBody>
+      </p:sp>
+    </p:spTree>
+  </p:cSld>
+  <p:clrMapOvr>
+    <a:masterClrMapping/>
+  </p:clrMapOvr>
+</p:sld>
+</file>
+
+<file path=ppt/slides/slide9.xml><?xml version="1.0" encoding="utf-8"?>
+<p:sld xmlns:a="http://schemas.openxmlformats.org/drawingml/2006/main" xmlns:p="http://schemas.openxmlformats.org/presentationml/2006/main" xmlns:r="http://schemas.openxmlformats.org/officeDocument/2006/relationships">
+  <p:cSld>
+    <p:spTree>
+      <p:nvGrpSpPr>
+        <p:cNvPr id="1" name=""/>
+        <p:cNvGrpSpPr/>
+        <p:nvPr/>
+      </p:nvGrpSpPr>
+      <p:grpSpPr/>
+      <p:sp>
+        <p:nvSpPr>
+          <p:cNvPr id="2" name="TextBox 1"/>
+          <p:cNvSpPr txBox="1"/>
+          <p:nvPr/>
+        </p:nvSpPr>
+        <p:spPr>
+          <a:xfrm>
+            <a:off x="457200" y="182880"/>
+            <a:ext cx="10972800" cy="457200"/>
+          </a:xfrm>
+          <a:prstGeom prst="rect">
+            <a:avLst/>
+          </a:prstGeom>
+          <a:noFill/>
+        </p:spPr>
+        <p:txBody>
+          <a:bodyPr wrap="none">
+            <a:spAutoFit/>
+          </a:bodyPr>
+          <a:lstStyle/>
+          <a:p>
+            <a:r>
+              <a:rPr sz="2000" b="1">
+                <a:solidFill>
+                  <a:srgbClr val="0C3250"/>
+                </a:solidFill>
+                <a:latin typeface="Calibri"/>
+              </a:rPr>
+              <a:t>Mapa atualizado — pontos EFC de nível + ANA</a:t>
+            </a:r>
+          </a:p>
+        </p:txBody>
+      </p:sp>
+      <p:pic>
+        <p:nvPicPr>
+          <p:cNvPr id="3" name="Picture 2" descr="image.png"/>
+          <p:cNvPicPr>
+            <a:picLocks noChangeAspect="1"/>
+          </p:cNvPicPr>
+          <p:nvPr/>
+        </p:nvPicPr>
+        <p:blipFill>
+          <a:blip r:embed="rId2"/>
+          <a:stretch>
+            <a:fillRect/>
+          </a:stretch>
+        </p:blipFill>
+        <p:spPr>
+          <a:xfrm>
+            <a:off x="502920" y="731520"/>
+            <a:ext cx="11155680" cy="7684797"/>
+          </a:xfrm>
+          <a:prstGeom prst="rect">
+            <a:avLst/>
+          </a:prstGeom>
+        </p:spPr>
+      </p:pic>
     </p:spTree>
   </p:cSld>
   <p:clrMapOvr>

</xml_diff>